<commit_message>
Add National Trend and Target Gaps evidence; align Hail share with Tableau
README lists the two new Tableau sheets and the Tayseer - Evidence dashboard. Deck slide 4 now uses unrounded gap shares, so Hail shows 2% as in Tableau.
</commit_message>
<xml_diff>
--- a/Tayseer_SAR40M_Capstone_Deck.pptx
+++ b/Tayseer_SAR40M_Capstone_Deck.pptx
@@ -113,23 +113,23 @@
   <p:extLst>
     <p:ext uri="{521415D9-36F7-43E2-AB2F-B90AF26B5E84}">
       <p14:sectionLst xmlns:p14="http://schemas.microsoft.com/office/powerpoint/2010/main">
-        <p14:section name="The decision" id="{c0bf2337-daee-4d15-0747-13910b60cb9a}">
+        <p14:section name="The decision" id="{3726491e-ebbc-6e07-420b-f82eeed1250c}">
           <p14:sldIdLst>
             <p14:sldId id="256"/>
           </p14:sldIdLst>
         </p14:section>
-        <p14:section name="Situation and complication" id="{43166fcf-0172-ad6d-5df0-22ba312a1a0d}">
+        <p14:section name="Situation and complication" id="{9a1af208-9808-3048-f982-f86d06c8c975}">
           <p14:sldIdLst>
             <p14:sldId id="257"/>
             <p14:sldId id="258"/>
           </p14:sldIdLst>
         </p14:section>
-        <p14:section name="Evidence" id="{461e75c5-dfbd-8614-7196-0b832129c67f}">
+        <p14:section name="Evidence" id="{4b21e99c-75cc-a8c7-e73e-2aa58a9fd472}">
           <p14:sldIdLst>
             <p14:sldId id="259"/>
           </p14:sldIdLst>
         </p14:section>
-        <p14:section name="Options, recommendation and ask" id="{6193fd9f-0d96-5ea3-4f0e-20701e9421db}">
+        <p14:section name="Options, recommendation and ask" id="{6e8629d2-65c1-2d23-0b28-6a8a0ad98f72}">
           <p14:sldIdLst>
             <p14:sldId id="260"/>
             <p14:sldId id="261"/>
@@ -1740,28 +1740,28 @@
                 <c:formatCode>General</c:formatCode>
                 <c:ptCount val="8"/>
                 <c:pt idx="0">
-                  <c:v>31.1</c:v>
+                  <c:v>31.082529474812432</c:v>
                 </c:pt>
                 <c:pt idx="1">
-                  <c:v>19.6</c:v>
+                  <c:v>19.614147909967848</c:v>
                 </c:pt>
                 <c:pt idx="2">
-                  <c:v>16.9</c:v>
+                  <c:v>16.934619506966776</c:v>
                 </c:pt>
                 <c:pt idx="3">
-                  <c:v>16.4</c:v>
+                  <c:v>16.39871382636656</c:v>
                 </c:pt>
                 <c:pt idx="4">
-                  <c:v>6.9</c:v>
+                  <c:v>6.859592711682744</c:v>
                 </c:pt>
                 <c:pt idx="5">
-                  <c:v>4.9</c:v>
+                  <c:v>4.930332261521972</c:v>
                 </c:pt>
                 <c:pt idx="6">
-                  <c:v>2.5</c:v>
+                  <c:v>2.465166130760986</c:v>
                 </c:pt>
                 <c:pt idx="7">
-                  <c:v>1.7</c:v>
+                  <c:v>1.714898177920686</c:v>
                 </c:pt>
               </c:numCache>
             </c:numRef>

</xml_diff>

<commit_message>
Add teammate Muaied Alsharef to the deck and README
</commit_message>
<xml_diff>
--- a/Tayseer_SAR40M_Capstone_Deck.pptx
+++ b/Tayseer_SAR40M_Capstone_Deck.pptx
@@ -113,23 +113,23 @@
   <p:extLst>
     <p:ext uri="{521415D9-36F7-43E2-AB2F-B90AF26B5E84}">
       <p14:sectionLst xmlns:p14="http://schemas.microsoft.com/office/powerpoint/2010/main">
-        <p14:section name="The decision" id="{3726491e-ebbc-6e07-420b-f82eeed1250c}">
+        <p14:section name="The decision" id="{fc1b5ea2-3c6b-3b51-5036-1df46a06d8b3}">
           <p14:sldIdLst>
             <p14:sldId id="256"/>
           </p14:sldIdLst>
         </p14:section>
-        <p14:section name="Situation and complication" id="{9a1af208-9808-3048-f982-f86d06c8c975}">
+        <p14:section name="Situation and complication" id="{b5acd35f-bc2d-de02-c422-ec6f613520dd}">
           <p14:sldIdLst>
             <p14:sldId id="257"/>
             <p14:sldId id="258"/>
           </p14:sldIdLst>
         </p14:section>
-        <p14:section name="Evidence" id="{4b21e99c-75cc-a8c7-e73e-2aa58a9fd472}">
+        <p14:section name="Evidence" id="{ad1322dc-63c4-ae3a-49f2-0aeeed8401c0}">
           <p14:sldIdLst>
             <p14:sldId id="259"/>
           </p14:sldIdLst>
         </p14:section>
-        <p14:section name="Options, recommendation and ask" id="{6e8629d2-65c1-2d23-0b28-6a8a0ad98f72}">
+        <p14:section name="Options, recommendation and ask" id="{8df13248-40b0-9bcc-af10-d18ec84dfeed}">
           <p14:sldIdLst>
             <p14:sldId id="260"/>
             <p14:sldId id="261"/>
@@ -2973,7 +2973,7 @@
           <a:p>
             <a:r>
               <a:rPr lang="en-US" dirty="0"/>
-              <a:t>PRESENTER: [Partner name]. TIME: 4:00-5:15.
+              <a:t>PRESENTER: Muaied Alsharef. TIME: 4:00-5:15.
 Orient: "We compared three realistic uses of the SAR 40M on one test - the middle row: how much of the money reaches the four regions that hold 84% of the gap."
 Option A: "Splitting evenly - 5 million to each of the eight regions - is simple and fair, but half the money goes to Asir, Tabuk, Hail and Al-Jouf, which are already within 0.7 points of target."
 Option C: "A single national campaign lifts everyone, but because spending follows users, only about 23% reaches the priority four and 48% lands in regions already above 65%."
@@ -3067,7 +3067,7 @@
           <a:p>
             <a:r>
               <a:rPr lang="en-US" dirty="0"/>
-              <a:t>PRESENTER: [Partner name]. TIME: 5:15-6:15.
+              <a:t>PRESENTER: Muaied Alsharef. TIME: 5:15-6:15.
 "We recommend Option B." Orient on the chart: "This is how the 40 million is split: Najran 13.5, Northern Borders 8.5, Al-Baha 7, Jazan 7, and a 4 million reserve. Each amount follows the region's share of the gap, so the rule is transparent and repeatable."
 Three reasons: (1) 90% of the money reaches 84% of the gap. (2) Najran is the slowest case - about 19 months to 65% on its own. (3) We know what to fund: in these regions branches and call centres still handle about 34% of transactions. In 2025 an assisted transaction cost SAR 24.08 (branch) or 23.09 (call centre) versus 15.01 on the app, and satisfaction is lower (CSAT 3.80 branch vs 4.08 app). Complaints is the weakest service in the below-target regions at 58.8% digital.
 Expected effect: all 13 regions at or above 65% within 12 months.
@@ -3160,7 +3160,7 @@
           <a:p>
             <a:r>
               <a:rPr lang="en-US" dirty="0"/>
-              <a:t>PRESENTER: [Partner name]. TIME: 6:15-7:00. Restate the Ask exactly as on slide 1.
+              <a:t>PRESENTER: Muaied Alsharef. TIME: 6:15-7:00. Restate the Ask exactly as on slide 1.
 "Our ask today: approve SAR 36 million for Najran, Northern Borders, Al-Baha and Jazan, split by their share of the gap, and hold 4 million in reserve. At month 6 we check two things on the Tableau dashboard: has each funded region closed at least half its gap - for Najran that means at least 62.9% - and has every near-miss region crossed 65%? Any that has not receives the reserve. Our target is every region at or above 65% within 12 months."
 Close with the Big Idea: "Tayseer has passed 65% nationally. Reaching it in every region is now a targeting decision, and the evidence points to four regions." Then invite questions.
 Month-6 half-gap thresholds: Najran 62.9%, Northern Borders 63.9%, Al-Baha 63.9%, Jazan 64.0%.</a:t>
@@ -3367,7 +3367,7 @@
                   <a:srgbClr val="D6E0DA"/>
                 </a:solidFill>
               </a:rPr>
-              <a:t>SDAIA Academy · SDA-DSC-112 Capstone · Naif Alnasser &amp; [Partner name]</a:t>
+              <a:t>SDAIA Academy · SDA-DSC-112 Capstone · Naif Alnasser &amp; Muaied Alsharef</a:t>
             </a:r>
             <a:endParaRPr lang="en-US" sz="1100" dirty="0"/>
           </a:p>
@@ -3558,7 +3558,7 @@
                   <a:srgbClr val="D6E0DA"/>
                 </a:solidFill>
               </a:rPr>
-              <a:t>SDAIA Academy · SDA-DSC-112 Capstone · Naif Alnasser &amp; [Partner name]</a:t>
+              <a:t>SDAIA Academy · SDA-DSC-112 Capstone · Naif Alnasser &amp; Muaied Alsharef</a:t>
             </a:r>
             <a:endParaRPr lang="en-US" sz="1100" dirty="0"/>
           </a:p>

</xml_diff>

<commit_message>
Final check: name Tableau sheets in slide footers, add GitHub usernames, 2-decimal gap shares
</commit_message>
<xml_diff>
--- a/Tayseer_SAR40M_Capstone_Deck.pptx
+++ b/Tayseer_SAR40M_Capstone_Deck.pptx
@@ -113,23 +113,23 @@
   <p:extLst>
     <p:ext uri="{521415D9-36F7-43E2-AB2F-B90AF26B5E84}">
       <p14:sectionLst xmlns:p14="http://schemas.microsoft.com/office/powerpoint/2010/main">
-        <p14:section name="The decision" id="{fc1b5ea2-3c6b-3b51-5036-1df46a06d8b3}">
+        <p14:section name="The decision" id="{314a9d1c-a688-a1f1-75a8-73d2370c1e5a}">
           <p14:sldIdLst>
             <p14:sldId id="256"/>
           </p14:sldIdLst>
         </p14:section>
-        <p14:section name="Situation and complication" id="{b5acd35f-bc2d-de02-c422-ec6f613520dd}">
+        <p14:section name="Situation and complication" id="{fdf0b8d1-90a1-36fd-b5ad-1dbca8febf4a}">
           <p14:sldIdLst>
             <p14:sldId id="257"/>
             <p14:sldId id="258"/>
           </p14:sldIdLst>
         </p14:section>
-        <p14:section name="Evidence" id="{ad1322dc-63c4-ae3a-49f2-0aeeed8401c0}">
+        <p14:section name="Evidence" id="{c3cf1d1d-a977-4d14-dc00-be938442a020}">
           <p14:sldIdLst>
             <p14:sldId id="259"/>
           </p14:sldIdLst>
         </p14:section>
-        <p14:section name="Options, recommendation and ask" id="{8df13248-40b0-9bcc-af10-d18ec84dfeed}">
+        <p14:section name="Options, recommendation and ask" id="{f7c193ba-6fe2-800a-f936-93c5333e4461}">
           <p14:sldIdLst>
             <p14:sldId id="260"/>
             <p14:sldId id="261"/>
@@ -8428,7 +8428,7 @@
                   <a:schemeClr val="accent6"/>
                 </a:solidFill>
               </a:rPr>
-              <a:t>Evidence: Tableau KPI + national trend · adoption weighted by unique users · Jan 2022 to Dec 2025</a:t>
+              <a:t>Evidence: Tableau KPI + National Trend sheet · adoption weighted by unique users · Jan 2022 to Dec 2025</a:t>
             </a:r>
             <a:endParaRPr lang="en-US" sz="1100" dirty="0"/>
           </a:p>
@@ -12872,7 +12872,7 @@
                   <a:schemeClr val="accent6"/>
                 </a:solidFill>
               </a:rPr>
-              <a:t>Evidence: Tableau Regional Adoption + target gaps · Dec 2024 and Dec 2025</a:t>
+              <a:t>Evidence: Tableau Target Gaps sheet (Tayseer — Evidence dashboard) · Dec 2024 and Dec 2025</a:t>
             </a:r>
             <a:endParaRPr lang="en-US" sz="1100" dirty="0"/>
           </a:p>
@@ -14608,7 +14608,7 @@
                   <a:schemeClr val="accent6"/>
                 </a:solidFill>
               </a:rPr>
-              <a:t>Evidence: Tableau target gaps + channel cost and CSAT, 2025 · amounts rounded to SAR 0.5M</a:t>
+              <a:t>Evidence: Tableau Target Gaps sheet · channel cost and CSAT 2025 from analysis/analyze.py · amounts rounded to SAR 0.5M</a:t>
             </a:r>
             <a:endParaRPr lang="en-US" sz="1100" dirty="0"/>
           </a:p>

</xml_diff>